<commit_message>
Expand Global PIQA multilingual examples and refine series layouts and official screenshots
</commit_message>
<xml_diff>
--- a/slides/datasets-in-10-minutes-charxiv.pptx
+++ b/slides/datasets-in-10-minutes-charxiv.pptx
@@ -8087,7 +8087,7 @@
         </p:nvSpPr>
         <p:spPr>
           <a:xfrm>
-            <a:off x="594360" y="1389888"/>
+            <a:off x="594360" y="1526481"/>
             <a:ext cx="7955279" cy="201168"/>
           </a:xfrm>
           <a:prstGeom prst="rect">
@@ -8141,7 +8141,7 @@
         </p:nvSpPr>
         <p:spPr>
           <a:xfrm>
-            <a:off x="594360" y="1664208"/>
+            <a:off x="594360" y="1835668"/>
             <a:ext cx="7955279" cy="877824"/>
           </a:xfrm>
           <a:prstGeom prst="rect">
@@ -8195,7 +8195,7 @@
         </p:nvSpPr>
         <p:spPr>
           <a:xfrm>
-            <a:off x="594360" y="2651760"/>
+            <a:off x="594360" y="2647777"/>
             <a:ext cx="7955279" cy="201168"/>
           </a:xfrm>
           <a:prstGeom prst="rect">
@@ -8249,7 +8249,7 @@
         </p:nvSpPr>
         <p:spPr>
           <a:xfrm>
-            <a:off x="594360" y="2926080"/>
+            <a:off x="594360" y="2981145"/>
             <a:ext cx="7955279" cy="603504"/>
           </a:xfrm>
           <a:prstGeom prst="rect">
@@ -8303,7 +8303,7 @@
         </p:nvSpPr>
         <p:spPr>
           <a:xfrm>
-            <a:off x="594360" y="3675887"/>
+            <a:off x="594360" y="3510551"/>
             <a:ext cx="7955279" cy="384048"/>
           </a:xfrm>
           <a:prstGeom prst="rect">
@@ -8357,7 +8357,7 @@
         </p:nvSpPr>
         <p:spPr>
           <a:xfrm>
-            <a:off x="594360" y="4160520"/>
+            <a:off x="594360" y="4102015"/>
             <a:ext cx="7955279" cy="438912"/>
           </a:xfrm>
           <a:prstGeom prst="rect">
@@ -8842,7 +8842,7 @@
         </p:nvSpPr>
         <p:spPr>
           <a:xfrm>
-            <a:off x="594360" y="1389888"/>
+            <a:off x="594360" y="1457993"/>
             <a:ext cx="7955279" cy="201168"/>
           </a:xfrm>
           <a:prstGeom prst="rect">
@@ -8896,7 +8896,7 @@
         </p:nvSpPr>
         <p:spPr>
           <a:xfrm>
-            <a:off x="594360" y="1664208"/>
+            <a:off x="594360" y="1741779"/>
             <a:ext cx="7955279" cy="877824"/>
           </a:xfrm>
           <a:prstGeom prst="rect">
@@ -8950,7 +8950,7 @@
         </p:nvSpPr>
         <p:spPr>
           <a:xfrm>
-            <a:off x="594360" y="2651760"/>
+            <a:off x="594360" y="2503089"/>
             <a:ext cx="7955279" cy="201168"/>
           </a:xfrm>
           <a:prstGeom prst="rect">
@@ -9004,7 +9004,7 @@
         </p:nvSpPr>
         <p:spPr>
           <a:xfrm>
-            <a:off x="594360" y="2926080"/>
+            <a:off x="594360" y="2811058"/>
             <a:ext cx="7955279" cy="603504"/>
           </a:xfrm>
           <a:prstGeom prst="rect">
@@ -9058,7 +9058,7 @@
         </p:nvSpPr>
         <p:spPr>
           <a:xfrm>
-            <a:off x="594360" y="3675887"/>
+            <a:off x="594360" y="3630950"/>
             <a:ext cx="7955279" cy="384048"/>
           </a:xfrm>
           <a:prstGeom prst="rect">
@@ -9112,7 +9112,7 @@
         </p:nvSpPr>
         <p:spPr>
           <a:xfrm>
-            <a:off x="594360" y="4160520"/>
+            <a:off x="594360" y="4171613"/>
             <a:ext cx="7955279" cy="438912"/>
           </a:xfrm>
           <a:prstGeom prst="rect">
@@ -12756,7 +12756,7 @@
                 <a:ea typeface="Noto Sans CJK JP"/>
                 <a:cs typeface="Noto Sans"/>
               </a:rPr>
-              <a:t>CharXivの公式配布ファイル</a:t>
+              <a:t>CharXivの公式サイト</a:t>
             </a:r>
           </a:p>
         </p:txBody>
@@ -12804,21 +12804,74 @@
                 <a:ea typeface="Noto Sans CJK JP"/>
                 <a:cs typeface="Noto Sans"/>
               </a:rPr>
-              <a:t>CharXiv: 公開データ</a:t>
+              <a:t>CharXiv: 公式サイト</a:t>
+            </a:r>
+          </a:p>
+        </p:txBody>
+      </p:sp>
+      <p:sp>
+        <p:nvSpPr>
+          <p:cNvPr id="5" name="TextBox 4"/>
+          <p:cNvSpPr txBox="1"/>
+          <p:nvPr/>
+        </p:nvSpPr>
+        <p:spPr>
+          <a:xfrm>
+            <a:off x="502920" y="4690872"/>
+            <a:ext cx="8183879" cy="393192"/>
+          </a:xfrm>
+          <a:prstGeom prst="rect">
+            <a:avLst/>
+          </a:prstGeom>
+          <a:noFill/>
+        </p:spPr>
+        <p:txBody>
+          <a:bodyPr wrap="square" lIns="0" rIns="0" tIns="0" bIns="0">
+            <a:noAutofit/>
+          </a:bodyPr>
+          <a:lstStyle/>
+          <a:p>
+            <a:pPr algn="l">
+              <a:lnSpc>
+                <a:spcPct val="110000"/>
+              </a:lnSpc>
+              <a:spcBef>
+                <a:spcPts val="0"/>
+              </a:spcBef>
+              <a:spcAft>
+                <a:spcPts val="0"/>
+              </a:spcAft>
+              <a:buNone/>
+              <a:defRPr sz="810" b="0">
+                <a:solidFill>
+                  <a:srgbClr val="303437"/>
+                </a:solidFill>
+                <a:latin typeface="Noto Sans"/>
+              </a:defRPr>
+            </a:pPr>
+            <a:r>
+              <a:rPr sz="1000">
+                <a:solidFill>
+                  <a:srgbClr val="626669"/>
+                </a:solidFill>
+                <a:latin typeface="Noto Sans"/>
+                <a:hlinkClick r:id="rId5"/>
+              </a:rPr>
+              <a:t>https://charxiv.github.io/</a:t>
             </a:r>
           </a:p>
         </p:txBody>
       </p:sp>
       <p:pic>
         <p:nvPicPr>
-          <p:cNvPr id="4" name="Picture 3" descr="hf-page.png"/>
+          <p:cNvPr id="6" name="公式サイトの画面" descr="image.png"/>
           <p:cNvPicPr>
             <a:picLocks noChangeAspect="1"/>
           </p:cNvPicPr>
           <p:nvPr/>
         </p:nvPicPr>
         <p:blipFill>
-          <a:blip r:embed="rId2"/>
+          <a:blip r:embed="rId4"/>
           <a:stretch>
             <a:fillRect/>
           </a:stretch>
@@ -12826,101 +12879,13 @@
         <p:spPr>
           <a:xfrm>
             <a:off x="2274570" y="1481328"/>
-            <a:ext cx="4594859" cy="3063240"/>
+            <a:ext cx="4594858" cy="3063239"/>
           </a:xfrm>
           <a:prstGeom prst="rect">
             <a:avLst/>
           </a:prstGeom>
         </p:spPr>
       </p:pic>
-      <p:sp>
-        <p:nvSpPr>
-          <p:cNvPr id="5" name="TextBox 4"/>
-          <p:cNvSpPr txBox="1"/>
-          <p:nvPr/>
-        </p:nvSpPr>
-        <p:spPr>
-          <a:xfrm>
-            <a:off x="502920" y="4690872"/>
-            <a:ext cx="8183879" cy="393192"/>
-          </a:xfrm>
-          <a:prstGeom prst="rect">
-            <a:avLst/>
-          </a:prstGeom>
-          <a:noFill/>
-        </p:spPr>
-        <p:txBody>
-          <a:bodyPr wrap="square" lIns="0" rIns="0" tIns="0" bIns="0">
-            <a:noAutofit/>
-          </a:bodyPr>
-          <a:lstStyle/>
-          <a:p>
-            <a:pPr algn="l">
-              <a:lnSpc>
-                <a:spcPct val="112000"/>
-              </a:lnSpc>
-              <a:spcBef>
-                <a:spcPts val="0"/>
-              </a:spcBef>
-              <a:spcAft>
-                <a:spcPts val="0"/>
-              </a:spcAft>
-              <a:buNone/>
-              <a:defRPr sz="810" b="0">
-                <a:solidFill>
-                  <a:srgbClr val="303437"/>
-                </a:solidFill>
-                <a:latin typeface="Noto Sans"/>
-              </a:defRPr>
-            </a:pPr>
-            <a:r>
-              <a:rPr sz="810" b="0" lang="ja-JP" altLang="en-US">
-                <a:solidFill>
-                  <a:srgbClr val="626669"/>
-                </a:solidFill>
-                <a:latin typeface="Noto Sans"/>
-                <a:ea typeface="Noto Sans CJK JP"/>
-                <a:cs typeface="Noto Sans"/>
-              </a:rPr>
-              <a:t/>
-            </a:r>
-            <a:r>
-              <a:rPr sz="810" b="0" lang="ja-JP" altLang="en-US">
-                <a:solidFill>
-                  <a:srgbClr val="626669"/>
-                </a:solidFill>
-                <a:latin typeface="Noto Sans"/>
-                <a:ea typeface="Noto Sans CJK JP"/>
-                <a:cs typeface="Noto Sans"/>
-              </a:rPr>
-              <a:t>Wang et al. (2024). CharXiv / 公式配布。改訂 f441eb6。</a:t>
-            </a:r>
-            <a:r>
-              <a:rPr sz="810" b="0" lang="ja-JP" altLang="en-US">
-                <a:solidFill>
-                  <a:srgbClr val="626669"/>
-                </a:solidFill>
-                <a:latin typeface="Noto Sans"/>
-                <a:ea typeface="Noto Sans CJK JP"/>
-                <a:cs typeface="Noto Sans"/>
-              </a:rPr>
-              <a:t>  </a:t>
-            </a:r>
-            <a:r>
-              <a:rPr sz="810" b="0" lang="ja-JP" altLang="en-US">
-                <a:solidFill>
-                  <a:srgbClr val="626669"/>
-                </a:solidFill>
-                <a:latin typeface="Noto Sans"/>
-                <a:ea typeface="Noto Sans CJK JP"/>
-                <a:cs typeface="Noto Sans"/>
-                <a:hlinkClick r:id="rId3"/>
-              </a:rPr>
-              <a:t>https://huggingface.co/datasets/princeton-nlp/CharXiv</a:t>
-            </a:r>
-          </a:p>
-        </p:txBody>
-      </p:sp>
     </p:spTree>
   </p:cSld>
   <p:clrMapOvr>
@@ -19042,7 +19007,7 @@
         </p:nvSpPr>
         <p:spPr>
           <a:xfrm>
-            <a:off x="594360" y="1389888"/>
+            <a:off x="594360" y="1681459"/>
             <a:ext cx="7955279" cy="201168"/>
           </a:xfrm>
           <a:prstGeom prst="rect">
@@ -19096,7 +19061,7 @@
         </p:nvSpPr>
         <p:spPr>
           <a:xfrm>
-            <a:off x="594360" y="1664208"/>
+            <a:off x="594360" y="1990646"/>
             <a:ext cx="7955279" cy="877824"/>
           </a:xfrm>
           <a:prstGeom prst="rect">
@@ -19150,7 +19115,7 @@
         </p:nvSpPr>
         <p:spPr>
           <a:xfrm>
-            <a:off x="594360" y="2651760"/>
+            <a:off x="594360" y="2492799"/>
             <a:ext cx="7955279" cy="201168"/>
           </a:xfrm>
           <a:prstGeom prst="rect">
@@ -19204,7 +19169,7 @@
         </p:nvSpPr>
         <p:spPr>
           <a:xfrm>
-            <a:off x="594360" y="2926080"/>
+            <a:off x="594360" y="2826168"/>
             <a:ext cx="7955279" cy="603504"/>
           </a:xfrm>
           <a:prstGeom prst="rect">
@@ -19258,7 +19223,7 @@
         </p:nvSpPr>
         <p:spPr>
           <a:xfrm>
-            <a:off x="594360" y="3675887"/>
+            <a:off x="594360" y="3355573"/>
             <a:ext cx="7955279" cy="384048"/>
           </a:xfrm>
           <a:prstGeom prst="rect">
@@ -19312,7 +19277,7 @@
         </p:nvSpPr>
         <p:spPr>
           <a:xfrm>
-            <a:off x="594360" y="4160520"/>
+            <a:off x="594360" y="3947037"/>
             <a:ext cx="7955279" cy="438912"/>
           </a:xfrm>
           <a:prstGeom prst="rect">
@@ -19797,7 +19762,7 @@
         </p:nvSpPr>
         <p:spPr>
           <a:xfrm>
-            <a:off x="594360" y="1389888"/>
+            <a:off x="594360" y="1680824"/>
             <a:ext cx="7955279" cy="201168"/>
           </a:xfrm>
           <a:prstGeom prst="rect">
@@ -19851,7 +19816,7 @@
         </p:nvSpPr>
         <p:spPr>
           <a:xfrm>
-            <a:off x="594360" y="1664208"/>
+            <a:off x="594360" y="1990010"/>
             <a:ext cx="7955279" cy="877824"/>
           </a:xfrm>
           <a:prstGeom prst="rect">
@@ -19905,7 +19870,7 @@
         </p:nvSpPr>
         <p:spPr>
           <a:xfrm>
-            <a:off x="594360" y="2651760"/>
+            <a:off x="594360" y="2492164"/>
             <a:ext cx="7955279" cy="201168"/>
           </a:xfrm>
           <a:prstGeom prst="rect">
@@ -19959,7 +19924,7 @@
         </p:nvSpPr>
         <p:spPr>
           <a:xfrm>
-            <a:off x="594360" y="2926080"/>
+            <a:off x="594360" y="2825532"/>
             <a:ext cx="7955279" cy="603504"/>
           </a:xfrm>
           <a:prstGeom prst="rect">
@@ -20013,7 +19978,7 @@
         </p:nvSpPr>
         <p:spPr>
           <a:xfrm>
-            <a:off x="594360" y="3675887"/>
+            <a:off x="594360" y="3356209"/>
             <a:ext cx="7955279" cy="384048"/>
           </a:xfrm>
           <a:prstGeom prst="rect">
@@ -20067,7 +20032,7 @@
         </p:nvSpPr>
         <p:spPr>
           <a:xfrm>
-            <a:off x="594360" y="4160520"/>
+            <a:off x="594360" y="3947673"/>
             <a:ext cx="7955279" cy="438912"/>
           </a:xfrm>
           <a:prstGeom prst="rect">
@@ -20552,7 +20517,7 @@
         </p:nvSpPr>
         <p:spPr>
           <a:xfrm>
-            <a:off x="594360" y="1389888"/>
+            <a:off x="594360" y="1680824"/>
             <a:ext cx="7955279" cy="201168"/>
           </a:xfrm>
           <a:prstGeom prst="rect">
@@ -20606,7 +20571,7 @@
         </p:nvSpPr>
         <p:spPr>
           <a:xfrm>
-            <a:off x="594360" y="1664208"/>
+            <a:off x="594360" y="1990010"/>
             <a:ext cx="7955279" cy="877824"/>
           </a:xfrm>
           <a:prstGeom prst="rect">
@@ -20660,7 +20625,7 @@
         </p:nvSpPr>
         <p:spPr>
           <a:xfrm>
-            <a:off x="594360" y="2651760"/>
+            <a:off x="594360" y="2492164"/>
             <a:ext cx="7955279" cy="201168"/>
           </a:xfrm>
           <a:prstGeom prst="rect">
@@ -20714,7 +20679,7 @@
         </p:nvSpPr>
         <p:spPr>
           <a:xfrm>
-            <a:off x="594360" y="2926080"/>
+            <a:off x="594360" y="2825532"/>
             <a:ext cx="7955279" cy="603504"/>
           </a:xfrm>
           <a:prstGeom prst="rect">
@@ -20768,7 +20733,7 @@
         </p:nvSpPr>
         <p:spPr>
           <a:xfrm>
-            <a:off x="594360" y="3675887"/>
+            <a:off x="594360" y="3356209"/>
             <a:ext cx="7955279" cy="384048"/>
           </a:xfrm>
           <a:prstGeom prst="rect">
@@ -20822,7 +20787,7 @@
         </p:nvSpPr>
         <p:spPr>
           <a:xfrm>
-            <a:off x="594360" y="4160520"/>
+            <a:off x="594360" y="3947673"/>
             <a:ext cx="7955279" cy="438912"/>
           </a:xfrm>
           <a:prstGeom prst="rect">
@@ -21421,7 +21386,7 @@
         </p:nvSpPr>
         <p:spPr>
           <a:xfrm>
-            <a:off x="594360" y="1389888"/>
+            <a:off x="594360" y="1457437"/>
             <a:ext cx="7955279" cy="201168"/>
           </a:xfrm>
           <a:prstGeom prst="rect">
@@ -21475,7 +21440,7 @@
         </p:nvSpPr>
         <p:spPr>
           <a:xfrm>
-            <a:off x="594360" y="1664208"/>
+            <a:off x="594360" y="1741224"/>
             <a:ext cx="7955279" cy="877824"/>
           </a:xfrm>
           <a:prstGeom prst="rect">
@@ -21529,7 +21494,7 @@
         </p:nvSpPr>
         <p:spPr>
           <a:xfrm>
-            <a:off x="594360" y="2651760"/>
+            <a:off x="594360" y="2502534"/>
             <a:ext cx="7955279" cy="201168"/>
           </a:xfrm>
           <a:prstGeom prst="rect">
@@ -21583,7 +21548,7 @@
         </p:nvSpPr>
         <p:spPr>
           <a:xfrm>
-            <a:off x="594360" y="2926080"/>
+            <a:off x="594360" y="2810502"/>
             <a:ext cx="7955279" cy="603504"/>
           </a:xfrm>
           <a:prstGeom prst="rect">
@@ -21637,7 +21602,7 @@
         </p:nvSpPr>
         <p:spPr>
           <a:xfrm>
-            <a:off x="594360" y="3675887"/>
+            <a:off x="594360" y="3630395"/>
             <a:ext cx="7955279" cy="384048"/>
           </a:xfrm>
           <a:prstGeom prst="rect">
@@ -21691,7 +21656,7 @@
         </p:nvSpPr>
         <p:spPr>
           <a:xfrm>
-            <a:off x="594360" y="4160520"/>
+            <a:off x="594360" y="4171058"/>
             <a:ext cx="7955279" cy="438912"/>
           </a:xfrm>
           <a:prstGeom prst="rect">
@@ -22176,7 +22141,7 @@
         </p:nvSpPr>
         <p:spPr>
           <a:xfrm>
-            <a:off x="594360" y="1389888"/>
+            <a:off x="594360" y="1457437"/>
             <a:ext cx="7955279" cy="201168"/>
           </a:xfrm>
           <a:prstGeom prst="rect">
@@ -22230,7 +22195,7 @@
         </p:nvSpPr>
         <p:spPr>
           <a:xfrm>
-            <a:off x="594360" y="1664208"/>
+            <a:off x="594360" y="1741224"/>
             <a:ext cx="7955279" cy="877824"/>
           </a:xfrm>
           <a:prstGeom prst="rect">
@@ -22284,7 +22249,7 @@
         </p:nvSpPr>
         <p:spPr>
           <a:xfrm>
-            <a:off x="594360" y="2651760"/>
+            <a:off x="594360" y="2502534"/>
             <a:ext cx="7955279" cy="201168"/>
           </a:xfrm>
           <a:prstGeom prst="rect">
@@ -22338,7 +22303,7 @@
         </p:nvSpPr>
         <p:spPr>
           <a:xfrm>
-            <a:off x="594360" y="2926080"/>
+            <a:off x="594360" y="2810502"/>
             <a:ext cx="7955279" cy="603504"/>
           </a:xfrm>
           <a:prstGeom prst="rect">
@@ -22392,7 +22357,7 @@
         </p:nvSpPr>
         <p:spPr>
           <a:xfrm>
-            <a:off x="594360" y="3675887"/>
+            <a:off x="594360" y="3630395"/>
             <a:ext cx="7955279" cy="384048"/>
           </a:xfrm>
           <a:prstGeom prst="rect">
@@ -22446,7 +22411,7 @@
         </p:nvSpPr>
         <p:spPr>
           <a:xfrm>
-            <a:off x="594360" y="4160520"/>
+            <a:off x="594360" y="4171058"/>
             <a:ext cx="7955279" cy="438912"/>
           </a:xfrm>
           <a:prstGeom prst="rect">
@@ -22931,7 +22896,7 @@
         </p:nvSpPr>
         <p:spPr>
           <a:xfrm>
-            <a:off x="594360" y="1389888"/>
+            <a:off x="594360" y="1457437"/>
             <a:ext cx="7955279" cy="201168"/>
           </a:xfrm>
           <a:prstGeom prst="rect">
@@ -22985,7 +22950,7 @@
         </p:nvSpPr>
         <p:spPr>
           <a:xfrm>
-            <a:off x="594360" y="1664208"/>
+            <a:off x="594360" y="1741224"/>
             <a:ext cx="7955279" cy="877824"/>
           </a:xfrm>
           <a:prstGeom prst="rect">
@@ -23039,7 +23004,7 @@
         </p:nvSpPr>
         <p:spPr>
           <a:xfrm>
-            <a:off x="594360" y="2651760"/>
+            <a:off x="594360" y="2502534"/>
             <a:ext cx="7955279" cy="201168"/>
           </a:xfrm>
           <a:prstGeom prst="rect">
@@ -23093,7 +23058,7 @@
         </p:nvSpPr>
         <p:spPr>
           <a:xfrm>
-            <a:off x="594360" y="2926080"/>
+            <a:off x="594360" y="2810502"/>
             <a:ext cx="7955279" cy="603504"/>
           </a:xfrm>
           <a:prstGeom prst="rect">
@@ -23147,7 +23112,7 @@
         </p:nvSpPr>
         <p:spPr>
           <a:xfrm>
-            <a:off x="594360" y="3675887"/>
+            <a:off x="594360" y="3630395"/>
             <a:ext cx="7955279" cy="384048"/>
           </a:xfrm>
           <a:prstGeom prst="rect">
@@ -23201,7 +23166,7 @@
         </p:nvSpPr>
         <p:spPr>
           <a:xfrm>
-            <a:off x="594360" y="4160520"/>
+            <a:off x="594360" y="4171058"/>
             <a:ext cx="7955279" cy="438912"/>
           </a:xfrm>
           <a:prstGeom prst="rect">
@@ -23686,7 +23651,7 @@
         </p:nvSpPr>
         <p:spPr>
           <a:xfrm>
-            <a:off x="594360" y="1389888"/>
+            <a:off x="594360" y="1681459"/>
             <a:ext cx="7955279" cy="201168"/>
           </a:xfrm>
           <a:prstGeom prst="rect">
@@ -23740,7 +23705,7 @@
         </p:nvSpPr>
         <p:spPr>
           <a:xfrm>
-            <a:off x="594360" y="1664208"/>
+            <a:off x="594360" y="1990646"/>
             <a:ext cx="7955279" cy="877824"/>
           </a:xfrm>
           <a:prstGeom prst="rect">
@@ -23794,7 +23759,7 @@
         </p:nvSpPr>
         <p:spPr>
           <a:xfrm>
-            <a:off x="594360" y="2651760"/>
+            <a:off x="594360" y="2492799"/>
             <a:ext cx="7955279" cy="201168"/>
           </a:xfrm>
           <a:prstGeom prst="rect">
@@ -23848,7 +23813,7 @@
         </p:nvSpPr>
         <p:spPr>
           <a:xfrm>
-            <a:off x="594360" y="2926080"/>
+            <a:off x="594360" y="2826168"/>
             <a:ext cx="7955279" cy="603504"/>
           </a:xfrm>
           <a:prstGeom prst="rect">
@@ -23902,7 +23867,7 @@
         </p:nvSpPr>
         <p:spPr>
           <a:xfrm>
-            <a:off x="594360" y="3675887"/>
+            <a:off x="594360" y="3355573"/>
             <a:ext cx="7955279" cy="384048"/>
           </a:xfrm>
           <a:prstGeom prst="rect">
@@ -23956,7 +23921,7 @@
         </p:nvSpPr>
         <p:spPr>
           <a:xfrm>
-            <a:off x="594360" y="4160520"/>
+            <a:off x="594360" y="3947037"/>
             <a:ext cx="7955279" cy="438912"/>
           </a:xfrm>
           <a:prstGeom prst="rect">
@@ -24441,7 +24406,7 @@
         </p:nvSpPr>
         <p:spPr>
           <a:xfrm>
-            <a:off x="594360" y="1389888"/>
+            <a:off x="594360" y="1525846"/>
             <a:ext cx="7955279" cy="201168"/>
           </a:xfrm>
           <a:prstGeom prst="rect">
@@ -24495,7 +24460,7 @@
         </p:nvSpPr>
         <p:spPr>
           <a:xfrm>
-            <a:off x="594360" y="1664208"/>
+            <a:off x="594360" y="1835032"/>
             <a:ext cx="7955279" cy="877824"/>
           </a:xfrm>
           <a:prstGeom prst="rect">
@@ -24549,7 +24514,7 @@
         </p:nvSpPr>
         <p:spPr>
           <a:xfrm>
-            <a:off x="594360" y="2651760"/>
+            <a:off x="594360" y="2647142"/>
             <a:ext cx="7955279" cy="201168"/>
           </a:xfrm>
           <a:prstGeom prst="rect">
@@ -24603,7 +24568,7 @@
         </p:nvSpPr>
         <p:spPr>
           <a:xfrm>
-            <a:off x="594360" y="2926080"/>
+            <a:off x="594360" y="2980510"/>
             <a:ext cx="7955279" cy="603504"/>
           </a:xfrm>
           <a:prstGeom prst="rect">
@@ -24657,7 +24622,7 @@
         </p:nvSpPr>
         <p:spPr>
           <a:xfrm>
-            <a:off x="594360" y="3675887"/>
+            <a:off x="594360" y="3511187"/>
             <a:ext cx="7955279" cy="384048"/>
           </a:xfrm>
           <a:prstGeom prst="rect">
@@ -24711,7 +24676,7 @@
         </p:nvSpPr>
         <p:spPr>
           <a:xfrm>
-            <a:off x="594360" y="4160520"/>
+            <a:off x="594360" y="4102651"/>
             <a:ext cx="7955279" cy="438912"/>
           </a:xfrm>
           <a:prstGeom prst="rect">
@@ -25511,7 +25476,7 @@
         </p:nvSpPr>
         <p:spPr>
           <a:xfrm>
-            <a:off x="594360" y="1389888"/>
+            <a:off x="594360" y="1385010"/>
             <a:ext cx="7955279" cy="201168"/>
           </a:xfrm>
           <a:prstGeom prst="rect">
@@ -25565,7 +25530,7 @@
         </p:nvSpPr>
         <p:spPr>
           <a:xfrm>
-            <a:off x="594360" y="1664208"/>
+            <a:off x="594360" y="1643397"/>
             <a:ext cx="7955279" cy="877824"/>
           </a:xfrm>
           <a:prstGeom prst="rect">
@@ -25619,7 +25584,7 @@
         </p:nvSpPr>
         <p:spPr>
           <a:xfrm>
-            <a:off x="594360" y="2651760"/>
+            <a:off x="594360" y="2676561"/>
             <a:ext cx="7955279" cy="201168"/>
           </a:xfrm>
           <a:prstGeom prst="rect">
@@ -25673,7 +25638,7 @@
         </p:nvSpPr>
         <p:spPr>
           <a:xfrm>
-            <a:off x="594360" y="2926080"/>
+            <a:off x="594360" y="2959129"/>
             <a:ext cx="7955279" cy="603504"/>
           </a:xfrm>
           <a:prstGeom prst="rect">
@@ -25727,7 +25692,7 @@
         </p:nvSpPr>
         <p:spPr>
           <a:xfrm>
-            <a:off x="594360" y="3675887"/>
+            <a:off x="594360" y="3740922"/>
             <a:ext cx="7955279" cy="384048"/>
           </a:xfrm>
           <a:prstGeom prst="rect">
@@ -25781,7 +25746,7 @@
         </p:nvSpPr>
         <p:spPr>
           <a:xfrm>
-            <a:off x="594360" y="4160520"/>
+            <a:off x="594360" y="4243486"/>
             <a:ext cx="7955279" cy="438912"/>
           </a:xfrm>
           <a:prstGeom prst="rect">
@@ -26266,7 +26231,7 @@
         </p:nvSpPr>
         <p:spPr>
           <a:xfrm>
-            <a:off x="594360" y="1389888"/>
+            <a:off x="594360" y="1680824"/>
             <a:ext cx="7955279" cy="201168"/>
           </a:xfrm>
           <a:prstGeom prst="rect">
@@ -26320,7 +26285,7 @@
         </p:nvSpPr>
         <p:spPr>
           <a:xfrm>
-            <a:off x="594360" y="1664208"/>
+            <a:off x="594360" y="1990010"/>
             <a:ext cx="7955279" cy="877824"/>
           </a:xfrm>
           <a:prstGeom prst="rect">
@@ -26374,7 +26339,7 @@
         </p:nvSpPr>
         <p:spPr>
           <a:xfrm>
-            <a:off x="594360" y="2651760"/>
+            <a:off x="594360" y="2492164"/>
             <a:ext cx="7955279" cy="201168"/>
           </a:xfrm>
           <a:prstGeom prst="rect">
@@ -26428,7 +26393,7 @@
         </p:nvSpPr>
         <p:spPr>
           <a:xfrm>
-            <a:off x="594360" y="2926080"/>
+            <a:off x="594360" y="2825532"/>
             <a:ext cx="7955279" cy="603504"/>
           </a:xfrm>
           <a:prstGeom prst="rect">
@@ -26482,7 +26447,7 @@
         </p:nvSpPr>
         <p:spPr>
           <a:xfrm>
-            <a:off x="594360" y="3675887"/>
+            <a:off x="594360" y="3356209"/>
             <a:ext cx="7955279" cy="384048"/>
           </a:xfrm>
           <a:prstGeom prst="rect">
@@ -26536,7 +26501,7 @@
         </p:nvSpPr>
         <p:spPr>
           <a:xfrm>
-            <a:off x="594360" y="4160520"/>
+            <a:off x="594360" y="3947673"/>
             <a:ext cx="7955279" cy="438912"/>
           </a:xfrm>
           <a:prstGeom prst="rect">
@@ -33871,7 +33836,7 @@
         </p:nvSpPr>
         <p:spPr>
           <a:xfrm>
-            <a:off x="594360" y="1389888"/>
+            <a:off x="594360" y="1681459"/>
             <a:ext cx="7955279" cy="201168"/>
           </a:xfrm>
           <a:prstGeom prst="rect">
@@ -33925,7 +33890,7 @@
         </p:nvSpPr>
         <p:spPr>
           <a:xfrm>
-            <a:off x="594360" y="1664208"/>
+            <a:off x="594360" y="1990646"/>
             <a:ext cx="7955279" cy="877824"/>
           </a:xfrm>
           <a:prstGeom prst="rect">
@@ -33979,7 +33944,7 @@
         </p:nvSpPr>
         <p:spPr>
           <a:xfrm>
-            <a:off x="594360" y="2651760"/>
+            <a:off x="594360" y="2492799"/>
             <a:ext cx="7955279" cy="201168"/>
           </a:xfrm>
           <a:prstGeom prst="rect">
@@ -34033,7 +33998,7 @@
         </p:nvSpPr>
         <p:spPr>
           <a:xfrm>
-            <a:off x="594360" y="2926080"/>
+            <a:off x="594360" y="2826168"/>
             <a:ext cx="7955279" cy="603504"/>
           </a:xfrm>
           <a:prstGeom prst="rect">
@@ -34087,7 +34052,7 @@
         </p:nvSpPr>
         <p:spPr>
           <a:xfrm>
-            <a:off x="594360" y="3675887"/>
+            <a:off x="594360" y="3355573"/>
             <a:ext cx="7955279" cy="384048"/>
           </a:xfrm>
           <a:prstGeom prst="rect">
@@ -34141,7 +34106,7 @@
         </p:nvSpPr>
         <p:spPr>
           <a:xfrm>
-            <a:off x="594360" y="4160520"/>
+            <a:off x="594360" y="3947037"/>
             <a:ext cx="7955279" cy="438912"/>
           </a:xfrm>
           <a:prstGeom prst="rect">

</xml_diff>

<commit_message>
Proofread charxiv slides page by page with Gemini
</commit_message>
<xml_diff>
--- a/slides/datasets-in-10-minutes-charxiv.pptx
+++ b/slides/datasets-in-10-minutes-charxiv.pptx
@@ -364,13 +364,13 @@
               <c:strCache>
                 <c:ptCount val="3"/>
                 <c:pt idx="0">
-                  <c:v>5グラフ以上</c:v>
+                  <c:v>5サブプロット以上</c:v>
                 </c:pt>
                 <c:pt idx="1">
-                  <c:v>2〜4グラフ</c:v>
+                  <c:v>2〜4サブプロット</c:v>
                 </c:pt>
                 <c:pt idx="2">
-                  <c:v>1グラフ</c:v>
+                  <c:v>1サブプロット</c:v>
                 </c:pt>
               </c:strCache>
             </c:strRef>
@@ -7797,7 +7797,7 @@
                 <a:ea typeface="Noto Sans CJK JP"/>
                 <a:cs typeface="Noto Sans"/>
               </a:rPr>
-              <a:t>実例2：回答の中央値：図</a:t>
+              <a:t>実例2：回答の中央値（図）</a:t>
             </a:r>
           </a:p>
         </p:txBody>
@@ -8552,7 +8552,7 @@
                 <a:ea typeface="Noto Sans CJK JP"/>
                 <a:cs typeface="Noto Sans"/>
               </a:rPr>
-              <a:t>実例3：二重軸の傾向：図</a:t>
+              <a:t>実例3：二重軸の傾向（図）</a:t>
             </a:r>
           </a:p>
         </p:txBody>
@@ -9307,7 +9307,7 @@
                 <a:ea typeface="Noto Sans CJK JP"/>
                 <a:cs typeface="Noto Sans"/>
               </a:rPr>
-              <a:t>記述問題は、図の基本要素を読み取る</a:t>
+              <a:t>記述問題では図の基本要素を読み取る</a:t>
             </a:r>
           </a:p>
         </p:txBody>
@@ -11473,7 +11473,7 @@
                 <a:ea typeface="Noto Sans CJK JP"/>
                 <a:cs typeface="Noto Sans"/>
               </a:rPr>
-              <a:t>validation。人間にもモデルと同じ設問・回答指示を提示した。</a:t>
+              <a:t>検証セット（validation）を対象。人間にもモデルと同じ設問・回答指示を提示した。</a:t>
             </a:r>
           </a:p>
         </p:txBody>
@@ -13572,7 +13572,7 @@
                           <a:ea typeface="Noto Sans CJK JP"/>
                           <a:cs typeface="Noto Sans"/>
                         </a:rPr>
-                        <a:t>大学院生が10候補から、多様な図を選ぶ</a:t>
+                        <a:t>大学院生が10件の候補から、多様な図を選ぶ</a:t>
                       </a:r>
                     </a:p>
                   </a:txBody>
@@ -13939,7 +13939,7 @@
                 <a:ea typeface="Noto Sans CJK JP"/>
                 <a:cs typeface="Noto Sans"/>
               </a:rPr>
-              <a:t>推論問題では、GPT-4Vが生成した10組の質問・回答を提示する。大学院生が選ぶ、書き直す、または新しく書き、最終的な1組を決める。</a:t>
+              <a:t>推論問題では、GPT-4Vが生成した10組の質問・回答を提示する。大学院生が選択、修正、または新規作成し、最終的な1組を決める。</a:t>
             </a:r>
           </a:p>
           <a:p>
@@ -13969,7 +13969,7 @@
                 <a:ea typeface="Noto Sans CJK JP"/>
                 <a:cs typeface="Noto Sans"/>
               </a:rPr>
-              <a:t>図の収集は2023年11月、質問の注釈は2024年4月。選図と注釈にはLabel Studioを使った。</a:t>
+              <a:t>図の収集は2023年11月、質問の注釈は2024年4月。図の選定と注釈にはLabel Studioを使った。</a:t>
             </a:r>
           </a:p>
         </p:txBody>
@@ -15155,7 +15155,7 @@
                 <a:ea typeface="Noto Sans CJK JP"/>
                 <a:cs typeface="Noto Sans"/>
               </a:rPr>
-              <a:t>図ごとに4記述問題＋1推論問題。学習用の分割は設けていない。</a:t>
+              <a:t>図ごとに記述問題4問＋推論問題1問。学習用の分割は設けていない。</a:t>
             </a:r>
           </a:p>
         </p:txBody>
@@ -16597,7 +16597,7 @@
                 <a:ea typeface="Noto Sans CJK JP"/>
                 <a:cs typeface="Noto Sans"/>
               </a:rPr>
-              <a:t>配布されたサブプロット数を全2,323図で集計。複数を含む図は61.4%。</a:t>
+              <a:t>配布データの全2,323図でサブプロット数を集計。複数を含む図は61.4%。</a:t>
             </a:r>
           </a:p>
         </p:txBody>
@@ -16865,7 +16865,7 @@
                 <a:ea typeface="Noto Sans CJK JP"/>
                 <a:cs typeface="Noto Sans"/>
               </a:rPr>
-              <a:t>2024年の公開から、モデル評価に採用された</a:t>
+              <a:t>2024年の公開以降、モデル評価に採用されている</a:t>
             </a:r>
           </a:p>
         </p:txBody>
@@ -16978,7 +16978,7 @@
                 <a:ea typeface="Noto Sans CJK JP"/>
                 <a:cs typeface="Noto Sans"/>
               </a:rPr>
-              <a:t>Hugging Faceで画像とメタデータ、GitHubで質問・正解・評価コードを入手できる。</a:t>
+              <a:t>Hugging Faceで画像とメタデータを、GitHubで質問・正解・評価コードを入手できる。</a:t>
             </a:r>
           </a:p>
         </p:txBody>
@@ -17725,7 +17725,7 @@
                 <a:ea typeface="Noto Sans CJK JP"/>
                 <a:cs typeface="Noto Sans"/>
               </a:rPr>
-              <a:t>図を読む力と、情報を結びつける力を測る</a:t>
+              <a:t>まとめ：CharXivの構成と特徴</a:t>
             </a:r>
           </a:p>
         </p:txBody>
@@ -17778,7 +17778,7 @@
                 <a:ea typeface="Noto Sans CJK JP"/>
                 <a:cs typeface="Noto Sans"/>
               </a:rPr>
-              <a:t>CharXivは、科学論文から選んだ多様な図を使う評価。図の要素を読む4問と、比較・計算・判断を行う1問が、各図に付いている。</a:t>
+              <a:t>CharXivは、科学論文から選んだ多様な図を用いた評価ベンチマーク。図の要素を読み取る4問と、比較・計算・判断を行う1問が各図に付いている。</a:t>
             </a:r>
           </a:p>
           <a:p>
@@ -17808,7 +17808,7 @@
                 <a:ea typeface="Noto Sans CJK JP"/>
                 <a:cs typeface="Noto Sans"/>
               </a:rPr>
-              <a:t>2,323図をvalidation 1,000図とtest 1,323図へ分割。公開validationには、設問と参照正解を収録している。</a:t>
+              <a:t>計2,323図をvalidation 1,000図とtest 1,323図に分割。公開validationには、設問と参照正解を収録している。</a:t>
             </a:r>
           </a:p>
           <a:p>
@@ -18752,7 +18752,7 @@
                 <a:ea typeface="Noto Sans CJK JP"/>
                 <a:cs typeface="Noto Sans"/>
               </a:rPr>
-              <a:t>追加例1：構成を比べる散布図：図</a:t>
+              <a:t>追加例1：構成を比べる散布図（図）</a:t>
             </a:r>
           </a:p>
         </p:txBody>
@@ -19507,7 +19507,7 @@
                 <a:ea typeface="Noto Sans CJK JP"/>
                 <a:cs typeface="Noto Sans"/>
               </a:rPr>
-              <a:t>追加例2：閾値を下回る点を数える：図</a:t>
+              <a:t>追加例2：閾値を下回る点を数える（図）</a:t>
             </a:r>
           </a:p>
         </p:txBody>
@@ -23889,7 +23889,7 @@
                 <a:ea typeface="Noto Sans CJK JP"/>
                 <a:cs typeface="Noto Sans"/>
               </a:rPr>
-              <a:t>エポックに沿って、より速く下がる線の名前は何か。</a:t>
+              <a:t>エポックが進むにつれて、より速く下がる線の名前は何か。</a:t>
             </a:r>
           </a:p>
         </p:txBody>
@@ -26469,7 +26469,7 @@
                 <a:ea typeface="Noto Sans CJK JP"/>
                 <a:cs typeface="Noto Sans"/>
               </a:rPr>
-              <a:t>所要時間が2番目に大きいモデルの、正解率（%）を答えよ。</a:t>
+              <a:t>所要時間が2番目に長いモデルの正解率（%）を答えよ。</a:t>
             </a:r>
           </a:p>
         </p:txBody>
@@ -26577,7 +26577,7 @@
                 <a:ea typeface="Noto Sans CJK JP"/>
                 <a:cs typeface="Noto Sans"/>
               </a:rPr>
-              <a:t>横軸で2番目に右のXceptionを選び、縦軸の94%を読む。</a:t>
+              <a:t>横軸で右から2番目のXceptionを選び、縦軸の94%を読む。</a:t>
             </a:r>
           </a:p>
         </p:txBody>
@@ -30526,7 +30526,7 @@
                 <a:ea typeface="Noto Sans CJK JP"/>
                 <a:cs typeface="Noto Sans"/>
               </a:rPr>
-              <a:t>全2,323推論問題。配布フィールドqa_sourceを集計。</a:t>
+              <a:t>推論問題全2,323問。配布フィールドqa_sourceを集計。</a:t>
             </a:r>
           </a:p>
         </p:txBody>
@@ -30714,26 +30714,26 @@
               <a:spcAft>
                 <a:spcPts val="800"/>
               </a:spcAft>
-              <a:buSzPct val="63333"/>
+              <a:buSzPct val="70000"/>
               <a:buFont typeface="Noto Sans CJK JP"/>
               <a:buChar char="●"/>
-              <a:defRPr sz="2100" b="0">
-                <a:solidFill>
-                  <a:srgbClr val="303437"/>
-                </a:solidFill>
-                <a:latin typeface="Noto Sans"/>
-              </a:defRPr>
-            </a:pPr>
-            <a:r>
-              <a:rPr sz="2100" b="0" lang="ja-JP" altLang="en-US">
-                <a:solidFill>
-                  <a:srgbClr val="303437"/>
-                </a:solidFill>
-                <a:latin typeface="Noto Sans"/>
-                <a:ea typeface="Noto Sans CJK JP"/>
-                <a:cs typeface="Noto Sans"/>
-              </a:rPr>
-              <a:t>公式の評価パイプラインは、2024年7月24日にバージョン1.0（v1.0）を公開した。この資料では2024年に公開されたCharXivのデータを参照する。</a:t>
+              <a:defRPr sz="1900" b="0">
+                <a:solidFill>
+                  <a:srgbClr val="303437"/>
+                </a:solidFill>
+                <a:latin typeface="Noto Sans"/>
+              </a:defRPr>
+            </a:pPr>
+            <a:r>
+              <a:rPr sz="1900" b="0" lang="ja-JP" altLang="en-US">
+                <a:solidFill>
+                  <a:srgbClr val="303437"/>
+                </a:solidFill>
+                <a:latin typeface="Noto Sans"/>
+                <a:ea typeface="Noto Sans CJK JP"/>
+                <a:cs typeface="Noto Sans"/>
+              </a:rPr>
+              <a:t>公式の評価パイプラインは、2024年7月24日にバージョン1.0（v1.0）が公開された。この資料では2024年に公開されたCharXivのデータを参照する。</a:t>
             </a:r>
           </a:p>
           <a:p>
@@ -30744,26 +30744,26 @@
               <a:spcAft>
                 <a:spcPts val="800"/>
               </a:spcAft>
-              <a:buSzPct val="63333"/>
+              <a:buSzPct val="70000"/>
               <a:buFont typeface="Noto Sans CJK JP"/>
               <a:buChar char="●"/>
-              <a:defRPr sz="2100" b="0">
-                <a:solidFill>
-                  <a:srgbClr val="303437"/>
-                </a:solidFill>
-                <a:latin typeface="Noto Sans"/>
-              </a:defRPr>
-            </a:pPr>
-            <a:r>
-              <a:rPr sz="2100" b="0" lang="ja-JP" altLang="en-US">
-                <a:solidFill>
-                  <a:srgbClr val="303437"/>
-                </a:solidFill>
-                <a:latin typeface="Noto Sans"/>
-                <a:ea typeface="Noto Sans CJK JP"/>
-                <a:cs typeface="Noto Sans"/>
-              </a:rPr>
-              <a:t>この資料はHugging Faceの改訂f441eb6と公式JSONを使用。画像ZIPを取得し、2,323ファイルと両分割の図IDを照合した。</a:t>
+              <a:defRPr sz="1900" b="0">
+                <a:solidFill>
+                  <a:srgbClr val="303437"/>
+                </a:solidFill>
+                <a:latin typeface="Noto Sans"/>
+              </a:defRPr>
+            </a:pPr>
+            <a:r>
+              <a:rPr sz="1900" b="0" lang="ja-JP" altLang="en-US">
+                <a:solidFill>
+                  <a:srgbClr val="303437"/>
+                </a:solidFill>
+                <a:latin typeface="Noto Sans"/>
+                <a:ea typeface="Noto Sans CJK JP"/>
+                <a:cs typeface="Noto Sans"/>
+              </a:rPr>
+              <a:t>この資料ではHugging Faceの改訂f441eb6と公式JSONを使用している。画像ZIPを取得し、2,323ファイルと両分割の図IDを照合した。</a:t>
             </a:r>
           </a:p>
           <a:p>
@@ -30774,26 +30774,26 @@
               <a:spcAft>
                 <a:spcPts val="0"/>
               </a:spcAft>
-              <a:buSzPct val="63333"/>
+              <a:buSzPct val="70000"/>
               <a:buFont typeface="Noto Sans CJK JP"/>
               <a:buChar char="●"/>
-              <a:defRPr sz="2100" b="0">
-                <a:solidFill>
-                  <a:srgbClr val="303437"/>
-                </a:solidFill>
-                <a:latin typeface="Noto Sans"/>
-              </a:defRPr>
-            </a:pPr>
-            <a:r>
-              <a:rPr sz="2100" b="0" lang="ja-JP" altLang="en-US">
-                <a:solidFill>
-                  <a:srgbClr val="303437"/>
-                </a:solidFill>
-                <a:latin typeface="Noto Sans"/>
-                <a:ea typeface="Noto Sans CJK JP"/>
-                <a:cs typeface="Noto Sans"/>
-              </a:rPr>
-              <a:t>validationは設問・参照正解を公開し、testは参照正解を非公開とする。掲載した13件はすべてvalidationに属する。</a:t>
+              <a:defRPr sz="1900" b="0">
+                <a:solidFill>
+                  <a:srgbClr val="303437"/>
+                </a:solidFill>
+                <a:latin typeface="Noto Sans"/>
+              </a:defRPr>
+            </a:pPr>
+            <a:r>
+              <a:rPr sz="1900" b="0" lang="ja-JP" altLang="en-US">
+                <a:solidFill>
+                  <a:srgbClr val="303437"/>
+                </a:solidFill>
+                <a:latin typeface="Noto Sans"/>
+                <a:ea typeface="Noto Sans CJK JP"/>
+                <a:cs typeface="Noto Sans"/>
+              </a:rPr>
+              <a:t>validationでは設問・参照正解が公開され、testでは参照正解が非公開とされている。掲載した13件はすべてvalidationに属する。</a:t>
             </a:r>
           </a:p>
         </p:txBody>
@@ -31078,7 +31078,7 @@
                 <a:ea typeface="Noto Sans CJK JP"/>
                 <a:cs typeface="Noto Sans"/>
               </a:rPr>
-              <a:t>著者らは既存評価の図や質問を変える実験を行い、モデルの得点が大きく下がる場合を示した。そこで、図の見た目と問い方の多様性を広げた。</a:t>
+              <a:t>著者らは既存評価の図や質問を変える実験を行い、モデルの得点が大きく下がる場合を示した。そこで、図の見た目と問い方の幅を広げた。</a:t>
             </a:r>
           </a:p>
         </p:txBody>
@@ -31280,7 +31280,7 @@
                 <a:ea typeface="Noto Sans CJK JP"/>
                 <a:cs typeface="Noto Sans"/>
               </a:rPr>
-              <a:t>設問と図では、利用条件が異なる</a:t>
+              <a:t>データ・図・コードで利用条件が異なる</a:t>
             </a:r>
           </a:p>
         </p:txBody>
@@ -31762,7 +31762,7 @@
                 <a:ea typeface="Noto Sans CJK JP"/>
                 <a:cs typeface="Noto Sans"/>
               </a:rPr>
-              <a:t>第一著者はZirui Wang、最終著者はDanqi Chen。論文はPrinceton Language and Intelligence（PLI）などの所属を記載している。</a:t>
+              <a:t>第一著者はZirui Wang、最終著者はDanqi Chen。論文にはPrinceton Language and Intelligence（PLI）などの所属が記載されている。</a:t>
             </a:r>
           </a:p>
           <a:p>
@@ -32193,7 +32193,7 @@
                 <a:ea typeface="Noto Sans CJK JP"/>
                 <a:cs typeface="Noto Sans"/>
               </a:rPr>
-              <a:t>選図・注釈・採点と、初期モデルの評価を報告する。</a:t>
+              <a:t>図の選定・注釈・採点と、初期モデルの評価を報告する。</a:t>
             </a:r>
           </a:p>
           <a:p>
@@ -33298,7 +33298,7 @@
                 <a:spcPts val="2640"/>
               </a:lnSpc>
               <a:spcAft>
-                <a:spcPts val="800"/>
+                <a:spcPts val="0"/>
               </a:spcAft>
               <a:buSzPct val="60455"/>
               <a:buFont typeface="Noto Sans CJK JP"/>
@@ -33319,7 +33319,7 @@
                 <a:ea typeface="Noto Sans CJK JP"/>
                 <a:cs typeface="Noto Sans"/>
               </a:rPr>
-              <a:t>本編は、学習曲線の急な変化、アンケート回答の中央値、二重軸の傾向を扱う3件。図と、設問・日本語訳・配布正解を別ページで示す。</a:t>
+              <a:t>全体はvalidation 1,000図とtest 1,323図。testの参照正解は公開せず、評価用に保持している。</a:t>
             </a:r>
           </a:p>
           <a:p>
@@ -33349,7 +33349,7 @@
                 <a:ea typeface="Noto Sans CJK JP"/>
                 <a:cs typeface="Noto Sans"/>
               </a:rPr>
-              <a:t>Appendixは、散布図、積み上げ棒、ヒストグラム、ヒートマップなど、別の10件。すべて正解を公開しているvalidation集合から選んだ。</a:t>
+              <a:t>本編は、学習曲線の急な変化、アンケート回答の中央値、二重軸の傾向を扱う3件。図と、設問・日本語訳・配布正解を別ページで示す。</a:t>
             </a:r>
           </a:p>
           <a:p>
@@ -33358,7 +33358,7 @@
                 <a:spcPts val="2640"/>
               </a:lnSpc>
               <a:spcAft>
-                <a:spcPts val="0"/>
+                <a:spcPts val="800"/>
               </a:spcAft>
               <a:buSzPct val="60455"/>
               <a:buFont typeface="Noto Sans CJK JP"/>
@@ -33379,7 +33379,7 @@
                 <a:ea typeface="Noto Sans CJK JP"/>
                 <a:cs typeface="Noto Sans"/>
               </a:rPr>
-              <a:t>全体はvalidation 1,000図とtest 1,323図。testの参照正解は公開せず、評価用に保持している。</a:t>
+              <a:t>Appendixは、散布図、積み上げ棒、ヒストグラム、ヒートマップなど、別の10件。すべて正解が公開されているvalidation集合から選んだ。</a:t>
             </a:r>
           </a:p>
         </p:txBody>
@@ -33581,7 +33581,7 @@
                 <a:ea typeface="Noto Sans CJK JP"/>
                 <a:cs typeface="Noto Sans"/>
               </a:rPr>
-              <a:t>実例1：最も急に下がる区間：図</a:t>
+              <a:t>実例1：最も急に下がる区間（図）</a:t>
             </a:r>
           </a:p>
         </p:txBody>

</xml_diff>

<commit_message>
slides(charxiv): refine Japanese wording and pair translations
</commit_message>
<xml_diff>
--- a/slides/datasets-in-10-minutes-charxiv.pptx
+++ b/slides/datasets-in-10-minutes-charxiv.pptx
@@ -31328,7 +31328,7 @@
                 <a:ea typeface="Noto Sans CJK JP"/>
                 <a:cs typeface="Noto Sans"/>
               </a:rPr>
-              <a:t>図は原著論文からの引用で、権利は各原著者に帰属する。各図ページの下部に、原著の著者・タイトル・URLを記載した。</a:t>
+              <a:t>図は引用元の論文からの引用で、権利は各論文の著者に帰属する。各図ページの下部に、引用元の著者・タイトル・URLを記載した。</a:t>
             </a:r>
           </a:p>
           <a:p>
@@ -31471,7 +31471,7 @@
                 <a:ea typeface="Noto Sans CJK JP"/>
                 <a:cs typeface="Noto Sans"/>
               </a:rPr>
-              <a:t>Wang et al. CharXiv: データはCC BY-SA 4.0、図の権利は原著者に帰属。</a:t>
+              <a:t>Wang et al. CharXiv: データはCC BY-SA 4.0、図の権利は引用元の著者に帰属。</a:t>
             </a:r>
             <a:r>
               <a:rPr sz="810" b="0" lang="ja-JP" altLang="en-US">
@@ -33136,7 +33136,7 @@
                 <a:ea typeface="Noto Sans CJK JP"/>
                 <a:cs typeface="Noto Sans"/>
               </a:rPr>
-              <a:t>データとコードの利用条件を示し、図の権利が各原著者に属することを明記する。</a:t>
+              <a:t>データとコードの利用条件を示し、図の権利が各論文の著者に属することを明記する。</a:t>
             </a:r>
           </a:p>
           <a:p>

</xml_diff>

<commit_message>
Improve charxiv answer visibility and citation wording
</commit_message>
<xml_diff>
--- a/slides/datasets-in-10-minutes-charxiv.pptx
+++ b/slides/datasets-in-10-minutes-charxiv.pptx
@@ -8304,7 +8304,7 @@
         <p:spPr>
           <a:xfrm>
             <a:off x="594360" y="3510551"/>
-            <a:ext cx="7955279" cy="384048"/>
+            <a:ext cx="7955279" cy="424856"/>
           </a:xfrm>
           <a:prstGeom prst="rect">
             <a:avLst/>
@@ -8338,7 +8338,7 @@
             <a:r>
               <a:rPr sz="2100" b="1" lang="ja-JP" altLang="en-US">
                 <a:solidFill>
-                  <a:srgbClr val="B13731"/>
+                  <a:schemeClr val="accent1"/>
                 </a:solidFill>
                 <a:latin typeface="Noto Sans"/>
                 <a:ea typeface="Noto Sans CJK JP"/>
@@ -9059,7 +9059,7 @@
         <p:spPr>
           <a:xfrm>
             <a:off x="594360" y="3630950"/>
-            <a:ext cx="7955279" cy="384048"/>
+            <a:ext cx="7955279" cy="424688"/>
           </a:xfrm>
           <a:prstGeom prst="rect">
             <a:avLst/>
@@ -9093,7 +9093,7 @@
             <a:r>
               <a:rPr sz="2100" b="1" lang="ja-JP" altLang="en-US">
                 <a:solidFill>
-                  <a:srgbClr val="B13731"/>
+                  <a:schemeClr val="accent1"/>
                 </a:solidFill>
                 <a:latin typeface="Noto Sans"/>
                 <a:ea typeface="Noto Sans CJK JP"/>
@@ -19224,7 +19224,7 @@
         <p:spPr>
           <a:xfrm>
             <a:off x="594360" y="3355573"/>
-            <a:ext cx="7955279" cy="384048"/>
+            <a:ext cx="7955279" cy="424666"/>
           </a:xfrm>
           <a:prstGeom prst="rect">
             <a:avLst/>
@@ -19258,7 +19258,7 @@
             <a:r>
               <a:rPr sz="2100" b="1" lang="ja-JP" altLang="en-US">
                 <a:solidFill>
-                  <a:srgbClr val="B13731"/>
+                  <a:schemeClr val="accent1"/>
                 </a:solidFill>
                 <a:latin typeface="Noto Sans"/>
                 <a:ea typeface="Noto Sans CJK JP"/>
@@ -19979,7 +19979,7 @@
         <p:spPr>
           <a:xfrm>
             <a:off x="594360" y="3356209"/>
-            <a:ext cx="7955279" cy="384048"/>
+            <a:ext cx="7955279" cy="424754"/>
           </a:xfrm>
           <a:prstGeom prst="rect">
             <a:avLst/>
@@ -20013,7 +20013,7 @@
             <a:r>
               <a:rPr sz="2100" b="1" lang="ja-JP" altLang="en-US">
                 <a:solidFill>
-                  <a:srgbClr val="B13731"/>
+                  <a:schemeClr val="accent1"/>
                 </a:solidFill>
                 <a:latin typeface="Noto Sans"/>
                 <a:ea typeface="Noto Sans CJK JP"/>
@@ -20734,7 +20734,7 @@
         <p:spPr>
           <a:xfrm>
             <a:off x="594360" y="3356209"/>
-            <a:ext cx="7955279" cy="384048"/>
+            <a:ext cx="7955279" cy="424754"/>
           </a:xfrm>
           <a:prstGeom prst="rect">
             <a:avLst/>
@@ -20768,7 +20768,7 @@
             <a:r>
               <a:rPr sz="2100" b="1" lang="ja-JP" altLang="en-US">
                 <a:solidFill>
-                  <a:srgbClr val="B13731"/>
+                  <a:schemeClr val="accent1"/>
                 </a:solidFill>
                 <a:latin typeface="Noto Sans"/>
                 <a:ea typeface="Noto Sans CJK JP"/>
@@ -21603,7 +21603,7 @@
         <p:spPr>
           <a:xfrm>
             <a:off x="594360" y="3630395"/>
-            <a:ext cx="7955279" cy="384048"/>
+            <a:ext cx="7955279" cy="424532"/>
           </a:xfrm>
           <a:prstGeom prst="rect">
             <a:avLst/>
@@ -21637,7 +21637,7 @@
             <a:r>
               <a:rPr sz="2100" b="1" lang="ja-JP" altLang="en-US">
                 <a:solidFill>
-                  <a:srgbClr val="B13731"/>
+                  <a:schemeClr val="accent1"/>
                 </a:solidFill>
                 <a:latin typeface="Noto Sans"/>
                 <a:ea typeface="Noto Sans CJK JP"/>
@@ -22358,7 +22358,7 @@
         <p:spPr>
           <a:xfrm>
             <a:off x="594360" y="3630395"/>
-            <a:ext cx="7955279" cy="384048"/>
+            <a:ext cx="7955279" cy="424532"/>
           </a:xfrm>
           <a:prstGeom prst="rect">
             <a:avLst/>
@@ -22392,7 +22392,7 @@
             <a:r>
               <a:rPr sz="2100" b="1" lang="ja-JP" altLang="en-US">
                 <a:solidFill>
-                  <a:srgbClr val="B13731"/>
+                  <a:schemeClr val="accent1"/>
                 </a:solidFill>
                 <a:latin typeface="Noto Sans"/>
                 <a:ea typeface="Noto Sans CJK JP"/>
@@ -23113,7 +23113,7 @@
         <p:spPr>
           <a:xfrm>
             <a:off x="594360" y="3630395"/>
-            <a:ext cx="7955279" cy="384048"/>
+            <a:ext cx="7955279" cy="424532"/>
           </a:xfrm>
           <a:prstGeom prst="rect">
             <a:avLst/>
@@ -23147,7 +23147,7 @@
             <a:r>
               <a:rPr sz="2100" b="1" lang="ja-JP" altLang="en-US">
                 <a:solidFill>
-                  <a:srgbClr val="B13731"/>
+                  <a:schemeClr val="accent1"/>
                 </a:solidFill>
                 <a:latin typeface="Noto Sans"/>
                 <a:ea typeface="Noto Sans CJK JP"/>
@@ -23868,7 +23868,7 @@
         <p:spPr>
           <a:xfrm>
             <a:off x="594360" y="3355573"/>
-            <a:ext cx="7955279" cy="384048"/>
+            <a:ext cx="7955279" cy="424666"/>
           </a:xfrm>
           <a:prstGeom prst="rect">
             <a:avLst/>
@@ -23902,7 +23902,7 @@
             <a:r>
               <a:rPr sz="2100" b="1" lang="ja-JP" altLang="en-US">
                 <a:solidFill>
-                  <a:srgbClr val="B13731"/>
+                  <a:schemeClr val="accent1"/>
                 </a:solidFill>
                 <a:latin typeface="Noto Sans"/>
                 <a:ea typeface="Noto Sans CJK JP"/>
@@ -24623,7 +24623,7 @@
         <p:spPr>
           <a:xfrm>
             <a:off x="594360" y="3511187"/>
-            <a:ext cx="7955279" cy="384048"/>
+            <a:ext cx="7955279" cy="424576"/>
           </a:xfrm>
           <a:prstGeom prst="rect">
             <a:avLst/>
@@ -24657,7 +24657,7 @@
             <a:r>
               <a:rPr sz="2100" b="1" lang="ja-JP" altLang="en-US">
                 <a:solidFill>
-                  <a:srgbClr val="B13731"/>
+                  <a:schemeClr val="accent1"/>
                 </a:solidFill>
                 <a:latin typeface="Noto Sans"/>
                 <a:ea typeface="Noto Sans CJK JP"/>
@@ -25693,7 +25693,7 @@
         <p:spPr>
           <a:xfrm>
             <a:off x="594360" y="3740922"/>
-            <a:ext cx="7955279" cy="384048"/>
+            <a:ext cx="7955279" cy="424521"/>
           </a:xfrm>
           <a:prstGeom prst="rect">
             <a:avLst/>
@@ -25727,7 +25727,7 @@
             <a:r>
               <a:rPr sz="2100" b="1" lang="ja-JP" altLang="en-US">
                 <a:solidFill>
-                  <a:srgbClr val="B13731"/>
+                  <a:schemeClr val="accent1"/>
                 </a:solidFill>
                 <a:latin typeface="Noto Sans"/>
                 <a:ea typeface="Noto Sans CJK JP"/>
@@ -26448,7 +26448,7 @@
         <p:spPr>
           <a:xfrm>
             <a:off x="594360" y="3356209"/>
-            <a:ext cx="7955279" cy="384048"/>
+            <a:ext cx="7955279" cy="424754"/>
           </a:xfrm>
           <a:prstGeom prst="rect">
             <a:avLst/>
@@ -26482,7 +26482,7 @@
             <a:r>
               <a:rPr sz="2100" b="1" lang="ja-JP" altLang="en-US">
                 <a:solidFill>
-                  <a:srgbClr val="B13731"/>
+                  <a:schemeClr val="accent1"/>
                 </a:solidFill>
                 <a:latin typeface="Noto Sans"/>
                 <a:ea typeface="Noto Sans CJK JP"/>
@@ -34053,7 +34053,7 @@
         <p:spPr>
           <a:xfrm>
             <a:off x="594360" y="3355573"/>
-            <a:ext cx="7955279" cy="384048"/>
+            <a:ext cx="7955279" cy="424666"/>
           </a:xfrm>
           <a:prstGeom prst="rect">
             <a:avLst/>
@@ -34087,7 +34087,7 @@
             <a:r>
               <a:rPr sz="2100" b="1" lang="ja-JP" altLang="en-US">
                 <a:solidFill>
-                  <a:srgbClr val="B13731"/>
+                  <a:schemeClr val="accent1"/>
                 </a:solidFill>
                 <a:latin typeface="Noto Sans"/>
                 <a:ea typeface="Noto Sans CJK JP"/>

</xml_diff>